<commit_message>
Place archive photos into deck slides
</commit_message>
<xml_diff>
--- a/docs/strategy/ges2-service-cx-proposal.pptx
+++ b/docs/strategy/ges2-service-cx-proposal.pptx
@@ -2677,12 +2677,19 @@
           </a:p>
         </p:txBody>
       </p:sp>
-      <p:sp>
-        <p:nvSpPr>
-          <p:cNvPr id="4" name="Shape 2"/>
-          <p:cNvSpPr/>
-          <p:nvPr/>
-        </p:nvSpPr>
+      <p:pic>
+        <p:nvPicPr>
+          <p:cNvPr id="4" name="Image 0" descr="/home/user/ges-2/docs/strategy/deck-images/platforms.jpg">    </p:cNvPr>
+          <p:cNvPicPr>
+            <a:picLocks noChangeAspect="1"/>
+          </p:cNvPicPr>
+          <p:nvPr/>
+        </p:nvPicPr>
+        <p:blipFill>
+          <a:blip r:embed="rId1"/>
+          <a:srcRect l="0" r="0" t="0" b="0"/>
+          <a:stretch/>
+        </p:blipFill>
         <p:spPr>
           <a:xfrm>
             <a:off x="6309360" y="1691640"/>
@@ -2691,9 +2698,22 @@
           <a:prstGeom prst="rect">
             <a:avLst/>
           </a:prstGeom>
-          <a:solidFill>
-            <a:srgbClr val="EEEEEE"/>
-          </a:solidFill>
+        </p:spPr>
+      </p:pic>
+      <p:sp>
+        <p:nvSpPr>
+          <p:cNvPr id="5" name="Shape 2"/>
+          <p:cNvSpPr/>
+          <p:nvPr/>
+        </p:nvSpPr>
+        <p:spPr>
+          <a:xfrm>
+            <a:off x="6309360" y="1691640"/>
+            <a:ext cx="5239512" cy="4023360"/>
+          </a:xfrm>
+          <a:prstGeom prst="rect">
+            <a:avLst/>
+          </a:prstGeom>
           <a:ln w="6350">
             <a:solidFill>
               <a:srgbClr val="000000"/>
@@ -2701,45 +2721,6 @@
             <a:prstDash val="solid"/>
           </a:ln>
         </p:spPr>
-      </p:sp>
-      <p:sp>
-        <p:nvSpPr>
-          <p:cNvPr id="5" name="Text 3"/>
-          <p:cNvSpPr txBox="1"/>
-          <p:nvPr/>
-        </p:nvSpPr>
-        <p:spPr>
-          <a:xfrm>
-            <a:off x="6492240" y="3291840"/>
-            <a:ext cx="4873752" cy="822960"/>
-          </a:xfrm>
-          <a:prstGeom prst="rect">
-            <a:avLst/>
-          </a:prstGeom>
-          <a:noFill/>
-          <a:ln/>
-        </p:spPr>
-        <p:txBody>
-          <a:bodyPr wrap="square" lIns="0" tIns="0" rIns="0" bIns="0" rtlCol="0" anchor="ctr"/>
-          <a:lstStyle/>
-          <a:p>
-            <a:pPr algn="ctr" indent="0" marL="0">
-              <a:buNone/>
-            </a:pPr>
-            <a:r>
-              <a:rPr lang="en-US" sz="1000" dirty="0">
-                <a:solidFill>
-                  <a:srgbClr val="9CA3AF"/>
-                </a:solidFill>
-                <a:latin typeface="Arial" pitchFamily="34" charset="0"/>
-                <a:ea typeface="Arial" pitchFamily="34" charset="-122"/>
-                <a:cs typeface="Arial" pitchFamily="34" charset="-120"/>
-              </a:rPr>
-              <a:t>Фото: кафе или гардероб</a:t>
-            </a:r>
-            <a:endParaRPr lang="en-US" sz="1000" dirty="0"/>
-          </a:p>
-        </p:txBody>
       </p:sp>
     </p:spTree>
   </p:cSld>
@@ -3095,12 +3076,19 @@
           </a:p>
         </p:txBody>
       </p:sp>
-      <p:sp>
-        <p:nvSpPr>
-          <p:cNvPr id="7" name="Shape 5"/>
-          <p:cNvSpPr/>
-          <p:nvPr/>
-        </p:nvSpPr>
+      <p:pic>
+        <p:nvPicPr>
+          <p:cNvPr id="7" name="Image 0" descr="/home/user/ges-2/docs/strategy/deck-images/books.jpg">    </p:cNvPr>
+          <p:cNvPicPr>
+            <a:picLocks noChangeAspect="1"/>
+          </p:cNvPicPr>
+          <p:nvPr/>
+        </p:nvPicPr>
+        <p:blipFill>
+          <a:blip r:embed="rId1"/>
+          <a:srcRect l="0" r="0" t="0" b="0"/>
+          <a:stretch/>
+        </p:blipFill>
         <p:spPr>
           <a:xfrm>
             <a:off x="8229600" y="1691640"/>
@@ -3109,9 +3097,22 @@
           <a:prstGeom prst="rect">
             <a:avLst/>
           </a:prstGeom>
-          <a:solidFill>
-            <a:srgbClr val="EEEEEE"/>
-          </a:solidFill>
+        </p:spPr>
+      </p:pic>
+      <p:sp>
+        <p:nvSpPr>
+          <p:cNvPr id="8" name="Shape 5"/>
+          <p:cNvSpPr/>
+          <p:nvPr/>
+        </p:nvSpPr>
+        <p:spPr>
+          <a:xfrm>
+            <a:off x="8229600" y="1691640"/>
+            <a:ext cx="3319272" cy="3657600"/>
+          </a:xfrm>
+          <a:prstGeom prst="rect">
+            <a:avLst/>
+          </a:prstGeom>
           <a:ln w="6350">
             <a:solidFill>
               <a:srgbClr val="000000"/>
@@ -3122,46 +3123,7 @@
       </p:sp>
       <p:sp>
         <p:nvSpPr>
-          <p:cNvPr id="8" name="Text 6"/>
-          <p:cNvSpPr txBox="1"/>
-          <p:nvPr/>
-        </p:nvSpPr>
-        <p:spPr>
-          <a:xfrm>
-            <a:off x="8412480" y="3108960"/>
-            <a:ext cx="2953512" cy="822960"/>
-          </a:xfrm>
-          <a:prstGeom prst="rect">
-            <a:avLst/>
-          </a:prstGeom>
-          <a:noFill/>
-          <a:ln/>
-        </p:spPr>
-        <p:txBody>
-          <a:bodyPr wrap="square" lIns="0" tIns="0" rIns="0" bIns="0" rtlCol="0" anchor="ctr"/>
-          <a:lstStyle/>
-          <a:p>
-            <a:pPr algn="ctr" indent="0" marL="0">
-              <a:buNone/>
-            </a:pPr>
-            <a:r>
-              <a:rPr lang="en-US" sz="1000" dirty="0">
-                <a:solidFill>
-                  <a:srgbClr val="9CA3AF"/>
-                </a:solidFill>
-                <a:latin typeface="Arial" pitchFamily="34" charset="0"/>
-                <a:ea typeface="Arial" pitchFamily="34" charset="-122"/>
-                <a:cs typeface="Arial" pitchFamily="34" charset="-120"/>
-              </a:rPr>
-              <a:t>Фото: магазин ГЭС-2</a:t>
-            </a:r>
-            <a:endParaRPr lang="en-US" sz="1000" dirty="0"/>
-          </a:p>
-        </p:txBody>
-      </p:sp>
-      <p:sp>
-        <p:nvSpPr>
-          <p:cNvPr id="9" name="Shape 7"/>
+          <p:cNvPr id="9" name="Shape 6"/>
           <p:cNvSpPr/>
           <p:nvPr/>
         </p:nvSpPr>
@@ -3184,7 +3146,7 @@
       </p:sp>
       <p:sp>
         <p:nvSpPr>
-          <p:cNvPr id="10" name="Text 8"/>
+          <p:cNvPr id="10" name="Text 7"/>
           <p:cNvSpPr txBox="1"/>
           <p:nvPr/>
         </p:nvSpPr>
@@ -3517,12 +3479,19 @@
           </a:p>
         </p:txBody>
       </p:sp>
-      <p:sp>
-        <p:nvSpPr>
-          <p:cNvPr id="8" name="Shape 6"/>
-          <p:cNvSpPr/>
-          <p:nvPr/>
-        </p:nvSpPr>
+      <p:pic>
+        <p:nvPicPr>
+          <p:cNvPr id="8" name="Image 0" descr="/home/user/ges-2/docs/strategy/deck-images/facade.jpg">    </p:cNvPr>
+          <p:cNvPicPr>
+            <a:picLocks noChangeAspect="1"/>
+          </p:cNvPicPr>
+          <p:nvPr/>
+        </p:nvPicPr>
+        <p:blipFill>
+          <a:blip r:embed="rId1"/>
+          <a:srcRect l="0" r="0" t="0" b="0"/>
+          <a:stretch/>
+        </p:blipFill>
         <p:spPr>
           <a:xfrm>
             <a:off x="7589520" y="1691640"/>
@@ -3531,9 +3500,22 @@
           <a:prstGeom prst="rect">
             <a:avLst/>
           </a:prstGeom>
-          <a:solidFill>
-            <a:srgbClr val="EEEEEE"/>
-          </a:solidFill>
+        </p:spPr>
+      </p:pic>
+      <p:sp>
+        <p:nvSpPr>
+          <p:cNvPr id="9" name="Shape 6"/>
+          <p:cNvSpPr/>
+          <p:nvPr/>
+        </p:nvSpPr>
+        <p:spPr>
+          <a:xfrm>
+            <a:off x="7589520" y="1691640"/>
+            <a:ext cx="3959352" cy="4023360"/>
+          </a:xfrm>
+          <a:prstGeom prst="rect">
+            <a:avLst/>
+          </a:prstGeom>
           <a:ln w="6350">
             <a:solidFill>
               <a:srgbClr val="000000"/>
@@ -3541,62 +3523,6 @@
             <a:prstDash val="solid"/>
           </a:ln>
         </p:spPr>
-      </p:sp>
-      <p:sp>
-        <p:nvSpPr>
-          <p:cNvPr id="9" name="Text 7"/>
-          <p:cNvSpPr txBox="1"/>
-          <p:nvPr/>
-        </p:nvSpPr>
-        <p:spPr>
-          <a:xfrm>
-            <a:off x="7772400" y="3291840"/>
-            <a:ext cx="3593592" cy="822960"/>
-          </a:xfrm>
-          <a:prstGeom prst="rect">
-            <a:avLst/>
-          </a:prstGeom>
-          <a:noFill/>
-          <a:ln/>
-        </p:spPr>
-        <p:txBody>
-          <a:bodyPr wrap="square" lIns="0" tIns="0" rIns="0" bIns="0" rtlCol="0" anchor="ctr"/>
-          <a:lstStyle/>
-          <a:p>
-            <a:pPr algn="ctr" indent="0" marL="0">
-              <a:buNone/>
-            </a:pPr>
-            <a:r>
-              <a:rPr lang="en-US" sz="1000" dirty="0">
-                <a:solidFill>
-                  <a:srgbClr val="9CA3AF"/>
-                </a:solidFill>
-                <a:latin typeface="Arial" pitchFamily="34" charset="0"/>
-                <a:ea typeface="Arial" pitchFamily="34" charset="-122"/>
-                <a:cs typeface="Arial" pitchFamily="34" charset="-120"/>
-              </a:rPr>
-              <a:t>Фото: фасад ГЭС-2</a:t>
-            </a:r>
-            <a:endParaRPr lang="en-US" sz="1000" dirty="0"/>
-          </a:p>
-          <a:p>
-            <a:pPr algn="ctr" indent="0" marL="0">
-              <a:buNone/>
-            </a:pPr>
-            <a:r>
-              <a:rPr lang="en-US" sz="1000" dirty="0">
-                <a:solidFill>
-                  <a:srgbClr val="9CA3AF"/>
-                </a:solidFill>
-                <a:latin typeface="Arial" pitchFamily="34" charset="0"/>
-                <a:ea typeface="Arial" pitchFamily="34" charset="-122"/>
-                <a:cs typeface="Arial" pitchFamily="34" charset="-120"/>
-              </a:rPr>
-              <a:t>с Болотной набережной</a:t>
-            </a:r>
-            <a:endParaRPr lang="en-US" sz="1000" dirty="0"/>
-          </a:p>
-        </p:txBody>
       </p:sp>
     </p:spTree>
   </p:cSld>
@@ -4470,12 +4396,19 @@
           </a:ln>
         </p:spPr>
       </p:sp>
-      <p:sp>
-        <p:nvSpPr>
-          <p:cNvPr id="27" name="Shape 25"/>
-          <p:cNvSpPr/>
-          <p:nvPr/>
-        </p:nvSpPr>
+      <p:pic>
+        <p:nvPicPr>
+          <p:cNvPr id="27" name="Image 0" descr="/home/user/ges-2/docs/strategy/deck-images/prospekt.jpg">    </p:cNvPr>
+          <p:cNvPicPr>
+            <a:picLocks noChangeAspect="1"/>
+          </p:cNvPicPr>
+          <p:nvPr/>
+        </p:nvPicPr>
+        <p:blipFill>
+          <a:blip r:embed="rId1"/>
+          <a:srcRect l="0" r="0" t="0" b="0"/>
+          <a:stretch/>
+        </p:blipFill>
         <p:spPr>
           <a:xfrm>
             <a:off x="7040880" y="1691640"/>
@@ -4484,9 +4417,22 @@
           <a:prstGeom prst="rect">
             <a:avLst/>
           </a:prstGeom>
-          <a:solidFill>
-            <a:srgbClr val="EEEEEE"/>
-          </a:solidFill>
+        </p:spPr>
+      </p:pic>
+      <p:sp>
+        <p:nvSpPr>
+          <p:cNvPr id="28" name="Shape 25"/>
+          <p:cNvSpPr/>
+          <p:nvPr/>
+        </p:nvSpPr>
+        <p:spPr>
+          <a:xfrm>
+            <a:off x="7040880" y="1691640"/>
+            <a:ext cx="4507992" cy="4251960"/>
+          </a:xfrm>
+          <a:prstGeom prst="rect">
+            <a:avLst/>
+          </a:prstGeom>
           <a:ln w="6350">
             <a:solidFill>
               <a:srgbClr val="000000"/>
@@ -4494,45 +4440,6 @@
             <a:prstDash val="solid"/>
           </a:ln>
         </p:spPr>
-      </p:sp>
-      <p:sp>
-        <p:nvSpPr>
-          <p:cNvPr id="28" name="Text 26"/>
-          <p:cNvSpPr txBox="1"/>
-          <p:nvPr/>
-        </p:nvSpPr>
-        <p:spPr>
-          <a:xfrm>
-            <a:off x="7223760" y="3406140"/>
-            <a:ext cx="4142232" cy="822960"/>
-          </a:xfrm>
-          <a:prstGeom prst="rect">
-            <a:avLst/>
-          </a:prstGeom>
-          <a:noFill/>
-          <a:ln/>
-        </p:spPr>
-        <p:txBody>
-          <a:bodyPr wrap="square" lIns="0" tIns="0" rIns="0" bIns="0" rtlCol="0" anchor="ctr"/>
-          <a:lstStyle/>
-          <a:p>
-            <a:pPr algn="ctr" indent="0" marL="0">
-              <a:buNone/>
-            </a:pPr>
-            <a:r>
-              <a:rPr lang="en-US" sz="1000" dirty="0">
-                <a:solidFill>
-                  <a:srgbClr val="9CA3AF"/>
-                </a:solidFill>
-                <a:latin typeface="Arial" pitchFamily="34" charset="0"/>
-                <a:ea typeface="Arial" pitchFamily="34" charset="-122"/>
-                <a:cs typeface="Arial" pitchFamily="34" charset="-120"/>
-              </a:rPr>
-              <a:t>Фото: внутренний двор</a:t>
-            </a:r>
-            <a:endParaRPr lang="en-US" sz="1000" dirty="0"/>
-          </a:p>
-        </p:txBody>
       </p:sp>
     </p:spTree>
   </p:cSld>
@@ -5096,12 +5003,19 @@
           </a:p>
         </p:txBody>
       </p:sp>
-      <p:sp>
-        <p:nvSpPr>
-          <p:cNvPr id="3" name="Shape 1"/>
-          <p:cNvSpPr/>
-          <p:nvPr/>
-        </p:nvSpPr>
+      <p:pic>
+        <p:nvPicPr>
+          <p:cNvPr id="3" name="Image 0" descr="/home/user/ges-2/docs/strategy/deck-images/svody.jpg">    </p:cNvPr>
+          <p:cNvPicPr>
+            <a:picLocks noChangeAspect="1"/>
+          </p:cNvPicPr>
+          <p:nvPr/>
+        </p:nvPicPr>
+        <p:blipFill>
+          <a:blip r:embed="rId1"/>
+          <a:srcRect l="0" r="0" t="0" b="0"/>
+          <a:stretch/>
+        </p:blipFill>
         <p:spPr>
           <a:xfrm>
             <a:off x="640080" y="1691640"/>
@@ -5110,9 +5024,22 @@
           <a:prstGeom prst="rect">
             <a:avLst/>
           </a:prstGeom>
-          <a:solidFill>
-            <a:srgbClr val="EEEEEE"/>
-          </a:solidFill>
+        </p:spPr>
+      </p:pic>
+      <p:sp>
+        <p:nvSpPr>
+          <p:cNvPr id="4" name="Shape 1"/>
+          <p:cNvSpPr/>
+          <p:nvPr/>
+        </p:nvSpPr>
+        <p:spPr>
+          <a:xfrm>
+            <a:off x="640080" y="1691640"/>
+            <a:ext cx="4754880" cy="4114800"/>
+          </a:xfrm>
+          <a:prstGeom prst="rect">
+            <a:avLst/>
+          </a:prstGeom>
           <a:ln w="6350">
             <a:solidFill>
               <a:srgbClr val="000000"/>
@@ -5123,63 +5050,7 @@
       </p:sp>
       <p:sp>
         <p:nvSpPr>
-          <p:cNvPr id="4" name="Text 2"/>
-          <p:cNvSpPr txBox="1"/>
-          <p:nvPr/>
-        </p:nvSpPr>
-        <p:spPr>
-          <a:xfrm>
-            <a:off x="822960" y="3337560"/>
-            <a:ext cx="4389120" cy="822960"/>
-          </a:xfrm>
-          <a:prstGeom prst="rect">
-            <a:avLst/>
-          </a:prstGeom>
-          <a:noFill/>
-          <a:ln/>
-        </p:spPr>
-        <p:txBody>
-          <a:bodyPr wrap="square" lIns="0" tIns="0" rIns="0" bIns="0" rtlCol="0" anchor="ctr"/>
-          <a:lstStyle/>
-          <a:p>
-            <a:pPr algn="ctr" indent="0" marL="0">
-              <a:buNone/>
-            </a:pPr>
-            <a:r>
-              <a:rPr lang="en-US" sz="1000" dirty="0">
-                <a:solidFill>
-                  <a:srgbClr val="9CA3AF"/>
-                </a:solidFill>
-                <a:latin typeface="Arial" pitchFamily="34" charset="0"/>
-                <a:ea typeface="Arial" pitchFamily="34" charset="-122"/>
-                <a:cs typeface="Arial" pitchFamily="34" charset="-120"/>
-              </a:rPr>
-              <a:t>Фото: закулисье —</a:t>
-            </a:r>
-            <a:endParaRPr lang="en-US" sz="1000" dirty="0"/>
-          </a:p>
-          <a:p>
-            <a:pPr algn="ctr" indent="0" marL="0">
-              <a:buNone/>
-            </a:pPr>
-            <a:r>
-              <a:rPr lang="en-US" sz="1000" dirty="0">
-                <a:solidFill>
-                  <a:srgbClr val="9CA3AF"/>
-                </a:solidFill>
-                <a:latin typeface="Arial" pitchFamily="34" charset="0"/>
-                <a:ea typeface="Arial" pitchFamily="34" charset="-122"/>
-                <a:cs typeface="Arial" pitchFamily="34" charset="-120"/>
-              </a:rPr>
-              <a:t>монтаж выставки или «Своды»</a:t>
-            </a:r>
-            <a:endParaRPr lang="en-US" sz="1000" dirty="0"/>
-          </a:p>
-        </p:txBody>
-      </p:sp>
-      <p:sp>
-        <p:nvSpPr>
-          <p:cNvPr id="5" name="Text 3"/>
+          <p:cNvPr id="5" name="Text 2"/>
           <p:cNvSpPr txBox="1"/>
           <p:nvPr/>
         </p:nvSpPr>
@@ -5788,12 +5659,19 @@
           </a:p>
         </p:txBody>
       </p:sp>
-      <p:sp>
-        <p:nvSpPr>
-          <p:cNvPr id="13" name="Shape 11"/>
-          <p:cNvSpPr/>
-          <p:nvPr/>
-        </p:nvSpPr>
+      <p:pic>
+        <p:nvPicPr>
+          <p:cNvPr id="13" name="Image 0" descr="/home/user/ges-2/docs/strategy/deck-images/flow.jpg">    </p:cNvPr>
+          <p:cNvPicPr>
+            <a:picLocks noChangeAspect="1"/>
+          </p:cNvPicPr>
+          <p:nvPr/>
+        </p:nvPicPr>
+        <p:blipFill>
+          <a:blip r:embed="rId1"/>
+          <a:srcRect l="0" r="0" t="0" b="0"/>
+          <a:stretch/>
+        </p:blipFill>
         <p:spPr>
           <a:xfrm>
             <a:off x="6903720" y="1691640"/>
@@ -5802,9 +5680,22 @@
           <a:prstGeom prst="rect">
             <a:avLst/>
           </a:prstGeom>
-          <a:solidFill>
-            <a:srgbClr val="EEEEEE"/>
-          </a:solidFill>
+        </p:spPr>
+      </p:pic>
+      <p:sp>
+        <p:nvSpPr>
+          <p:cNvPr id="14" name="Shape 11"/>
+          <p:cNvSpPr/>
+          <p:nvPr/>
+        </p:nvSpPr>
+        <p:spPr>
+          <a:xfrm>
+            <a:off x="6903720" y="1691640"/>
+            <a:ext cx="4645152" cy="4114800"/>
+          </a:xfrm>
+          <a:prstGeom prst="rect">
+            <a:avLst/>
+          </a:prstGeom>
           <a:ln w="6350">
             <a:solidFill>
               <a:srgbClr val="000000"/>
@@ -5812,62 +5703,6 @@
             <a:prstDash val="solid"/>
           </a:ln>
         </p:spPr>
-      </p:sp>
-      <p:sp>
-        <p:nvSpPr>
-          <p:cNvPr id="14" name="Text 12"/>
-          <p:cNvSpPr txBox="1"/>
-          <p:nvPr/>
-        </p:nvSpPr>
-        <p:spPr>
-          <a:xfrm>
-            <a:off x="7086600" y="3337560"/>
-            <a:ext cx="4279392" cy="822960"/>
-          </a:xfrm>
-          <a:prstGeom prst="rect">
-            <a:avLst/>
-          </a:prstGeom>
-          <a:noFill/>
-          <a:ln/>
-        </p:spPr>
-        <p:txBody>
-          <a:bodyPr wrap="square" lIns="0" tIns="0" rIns="0" bIns="0" rtlCol="0" anchor="ctr"/>
-          <a:lstStyle/>
-          <a:p>
-            <a:pPr algn="ctr" indent="0" marL="0">
-              <a:buNone/>
-            </a:pPr>
-            <a:r>
-              <a:rPr lang="en-US" sz="1000" dirty="0">
-                <a:solidFill>
-                  <a:srgbClr val="9CA3AF"/>
-                </a:solidFill>
-                <a:latin typeface="Arial" pitchFamily="34" charset="0"/>
-                <a:ea typeface="Arial" pitchFamily="34" charset="-122"/>
-                <a:cs typeface="Arial" pitchFamily="34" charset="-120"/>
-              </a:rPr>
-              <a:t>Фото: собственный снимок</a:t>
-            </a:r>
-            <a:endParaRPr lang="en-US" sz="1000" dirty="0"/>
-          </a:p>
-          <a:p>
-            <a:pPr algn="ctr" indent="0" marL="0">
-              <a:buNone/>
-            </a:pPr>
-            <a:r>
-              <a:rPr lang="en-US" sz="1000" dirty="0">
-                <a:solidFill>
-                  <a:srgbClr val="9CA3AF"/>
-                </a:solidFill>
-                <a:latin typeface="Arial" pitchFamily="34" charset="0"/>
-                <a:ea typeface="Arial" pitchFamily="34" charset="-122"/>
-                <a:cs typeface="Arial" pitchFamily="34" charset="-120"/>
-              </a:rPr>
-              <a:t>с прохода пути — точка трения</a:t>
-            </a:r>
-            <a:endParaRPr lang="en-US" sz="1000" dirty="0"/>
-          </a:p>
-        </p:txBody>
       </p:sp>
     </p:spTree>
   </p:cSld>
@@ -7123,12 +6958,19 @@
           </a:p>
         </p:txBody>
       </p:sp>
-      <p:sp>
-        <p:nvSpPr>
-          <p:cNvPr id="3" name="Shape 1"/>
-          <p:cNvSpPr/>
-          <p:nvPr/>
-        </p:nvSpPr>
+      <p:pic>
+        <p:nvPicPr>
+          <p:cNvPr id="3" name="Image 0" descr="/home/user/ges-2/docs/strategy/deck-images/mediation.jpg">    </p:cNvPr>
+          <p:cNvPicPr>
+            <a:picLocks noChangeAspect="1"/>
+          </p:cNvPicPr>
+          <p:nvPr/>
+        </p:nvPicPr>
+        <p:blipFill>
+          <a:blip r:embed="rId1"/>
+          <a:srcRect l="0" r="0" t="0" b="0"/>
+          <a:stretch/>
+        </p:blipFill>
         <p:spPr>
           <a:xfrm>
             <a:off x="640080" y="1691640"/>
@@ -7137,9 +6979,22 @@
           <a:prstGeom prst="rect">
             <a:avLst/>
           </a:prstGeom>
-          <a:solidFill>
-            <a:srgbClr val="EEEEEE"/>
-          </a:solidFill>
+        </p:spPr>
+      </p:pic>
+      <p:sp>
+        <p:nvSpPr>
+          <p:cNvPr id="4" name="Shape 1"/>
+          <p:cNvSpPr/>
+          <p:nvPr/>
+        </p:nvSpPr>
+        <p:spPr>
+          <a:xfrm>
+            <a:off x="640080" y="1691640"/>
+            <a:ext cx="3931920" cy="4114800"/>
+          </a:xfrm>
+          <a:prstGeom prst="rect">
+            <a:avLst/>
+          </a:prstGeom>
           <a:ln w="6350">
             <a:solidFill>
               <a:srgbClr val="000000"/>
@@ -7150,63 +7005,7 @@
       </p:sp>
       <p:sp>
         <p:nvSpPr>
-          <p:cNvPr id="4" name="Text 2"/>
-          <p:cNvSpPr txBox="1"/>
-          <p:nvPr/>
-        </p:nvSpPr>
-        <p:spPr>
-          <a:xfrm>
-            <a:off x="822960" y="3337560"/>
-            <a:ext cx="3566160" cy="822960"/>
-          </a:xfrm>
-          <a:prstGeom prst="rect">
-            <a:avLst/>
-          </a:prstGeom>
-          <a:noFill/>
-          <a:ln/>
-        </p:spPr>
-        <p:txBody>
-          <a:bodyPr wrap="square" lIns="0" tIns="0" rIns="0" bIns="0" rtlCol="0" anchor="ctr"/>
-          <a:lstStyle/>
-          <a:p>
-            <a:pPr algn="ctr" indent="0" marL="0">
-              <a:buNone/>
-            </a:pPr>
-            <a:r>
-              <a:rPr lang="en-US" sz="1000" dirty="0">
-                <a:solidFill>
-                  <a:srgbClr val="9CA3AF"/>
-                </a:solidFill>
-                <a:latin typeface="Arial" pitchFamily="34" charset="0"/>
-                <a:ea typeface="Arial" pitchFamily="34" charset="-122"/>
-                <a:cs typeface="Arial" pitchFamily="34" charset="-120"/>
-              </a:rPr>
-              <a:t>Фото: сотрудник в диалоге</a:t>
-            </a:r>
-            <a:endParaRPr lang="en-US" sz="1000" dirty="0"/>
-          </a:p>
-          <a:p>
-            <a:pPr algn="ctr" indent="0" marL="0">
-              <a:buNone/>
-            </a:pPr>
-            <a:r>
-              <a:rPr lang="en-US" sz="1000" dirty="0">
-                <a:solidFill>
-                  <a:srgbClr val="9CA3AF"/>
-                </a:solidFill>
-                <a:latin typeface="Arial" pitchFamily="34" charset="0"/>
-                <a:ea typeface="Arial" pitchFamily="34" charset="-122"/>
-                <a:cs typeface="Arial" pitchFamily="34" charset="-120"/>
-              </a:rPr>
-              <a:t>с посетителем — лицо, не интерьер</a:t>
-            </a:r>
-            <a:endParaRPr lang="en-US" sz="1000" dirty="0"/>
-          </a:p>
-        </p:txBody>
-      </p:sp>
-      <p:sp>
-        <p:nvSpPr>
-          <p:cNvPr id="5" name="Text 3"/>
+          <p:cNvPr id="5" name="Text 2"/>
           <p:cNvSpPr txBox="1"/>
           <p:nvPr/>
         </p:nvSpPr>
@@ -7245,7 +7044,7 @@
       </p:sp>
       <p:sp>
         <p:nvSpPr>
-          <p:cNvPr id="6" name="Text 4"/>
+          <p:cNvPr id="6" name="Text 3"/>
           <p:cNvSpPr txBox="1"/>
           <p:nvPr/>
         </p:nvSpPr>
@@ -7363,7 +7162,7 @@
       </p:sp>
       <p:sp>
         <p:nvSpPr>
-          <p:cNvPr id="7" name="Text 5"/>
+          <p:cNvPr id="7" name="Text 4"/>
           <p:cNvSpPr txBox="1"/>
           <p:nvPr/>
         </p:nvSpPr>
@@ -7402,7 +7201,7 @@
       </p:sp>
       <p:sp>
         <p:nvSpPr>
-          <p:cNvPr id="8" name="Text 6"/>
+          <p:cNvPr id="8" name="Text 5"/>
           <p:cNvSpPr txBox="1"/>
           <p:nvPr/>
         </p:nvSpPr>

</xml_diff>

<commit_message>
Insert ges-2.org screenshot on digital services slide
</commit_message>
<xml_diff>
--- a/docs/strategy/ges2-service-cx-proposal.pptx
+++ b/docs/strategy/ges2-service-cx-proposal.pptx
@@ -1392,7 +1392,7 @@
           <a:p>
             <a:r>
               <a:rPr lang="en-US" dirty="0"/>
-              <a:t>Скриншот главной страницы сайта. Снимается самостоятельно - из этой среды внешние сайты недоступны.</a:t>
+              <a:t>Главная страница ges-2.org. Две точки трения видны прямо на экране: бегущая строка с режимом работы, которую нельзя перечитать, и кнопка «Регистрация на вход» без визуального приоритета, хотя это главное целевое действие посетителя.</a:t>
             </a:r>
             <a:endParaRPr lang="en-US" dirty="0"/>
           </a:p>
@@ -7178,23 +7178,44 @@
           </a:p>
         </p:txBody>
       </p:sp>
-      <p:sp>
-        <p:nvSpPr>
-          <p:cNvPr id="4" name="Shape 2"/>
+      <p:pic>
+        <p:nvPicPr>
+          <p:cNvPr id="4" name="Image 0" descr="/home/user/ges-2/docs/strategy/deck-images/site.jpg">    </p:cNvPr>
+          <p:cNvPicPr>
+            <a:picLocks noChangeAspect="1"/>
+          </p:cNvPicPr>
+          <p:nvPr/>
+        </p:nvPicPr>
+        <p:blipFill>
+          <a:blip r:embed="rId1"/>
+          <a:stretch>
+            <a:fillRect/>
+          </a:stretch>
+        </p:blipFill>
+        <p:spPr>
+          <a:xfrm>
+            <a:off x="5852160" y="2377440"/>
+            <a:ext cx="5696712" cy="2757230"/>
+          </a:xfrm>
+          <a:prstGeom prst="rect">
+            <a:avLst/>
+          </a:prstGeom>
+        </p:spPr>
+      </p:pic>
+      <p:sp>
+        <p:nvSpPr>
+          <p:cNvPr id="5" name="Shape 2"/>
           <p:cNvSpPr/>
           <p:nvPr/>
         </p:nvSpPr>
         <p:spPr>
           <a:xfrm>
-            <a:off x="5852160" y="2011680"/>
-            <a:ext cx="5696712" cy="3797808"/>
-          </a:xfrm>
-          <a:prstGeom prst="rect">
-            <a:avLst/>
-          </a:prstGeom>
-          <a:solidFill>
-            <a:srgbClr val="EEEEEE"/>
-          </a:solidFill>
+            <a:off x="5852160" y="2377440"/>
+            <a:ext cx="5696712" cy="2757230"/>
+          </a:xfrm>
+          <a:prstGeom prst="rect">
+            <a:avLst/>
+          </a:prstGeom>
           <a:ln w="6350">
             <a:solidFill>
               <a:srgbClr val="000000"/>
@@ -7202,45 +7223,6 @@
             <a:prstDash val="solid"/>
           </a:ln>
         </p:spPr>
-      </p:sp>
-      <p:sp>
-        <p:nvSpPr>
-          <p:cNvPr id="5" name="Text 3"/>
-          <p:cNvSpPr txBox="1"/>
-          <p:nvPr/>
-        </p:nvSpPr>
-        <p:spPr>
-          <a:xfrm>
-            <a:off x="6035040" y="3499104"/>
-            <a:ext cx="5330952" cy="822960"/>
-          </a:xfrm>
-          <a:prstGeom prst="rect">
-            <a:avLst/>
-          </a:prstGeom>
-          <a:noFill/>
-          <a:ln/>
-        </p:spPr>
-        <p:txBody>
-          <a:bodyPr wrap="square" lIns="0" tIns="0" rIns="0" bIns="0" rtlCol="0" anchor="ctr"/>
-          <a:lstStyle/>
-          <a:p>
-            <a:pPr algn="ctr" indent="0" marL="0">
-              <a:buNone/>
-            </a:pPr>
-            <a:r>
-              <a:rPr lang="en-US" sz="1100" dirty="0">
-                <a:solidFill>
-                  <a:srgbClr val="9CA3AF"/>
-                </a:solidFill>
-                <a:latin typeface="Arial" pitchFamily="34" charset="0"/>
-                <a:ea typeface="Arial" pitchFamily="34" charset="-122"/>
-                <a:cs typeface="Arial" pitchFamily="34" charset="-120"/>
-              </a:rPr>
-              <a:t>Скриншот ges-2.org</a:t>
-            </a:r>
-            <a:endParaRPr lang="en-US" sz="1100" dirty="0"/>
-          </a:p>
-        </p:txBody>
       </p:sp>
     </p:spTree>
   </p:cSld>

</xml_diff>

<commit_message>
Add slide numbering, rewrite slide 2 statements, sync contents, adjust mystery visit frequency
</commit_message>
<xml_diff>
--- a/docs/strategy/ges2-service-cx-proposal.pptx
+++ b/docs/strategy/ges2-service-cx-proposal.pptx
@@ -2024,7 +2024,7 @@
         <p:spPr>
           <a:xfrm>
             <a:off x="640080" y="457200"/>
-            <a:ext cx="10911535" cy="731520"/>
+            <a:ext cx="9144000" cy="731520"/>
           </a:xfrm>
           <a:prstGeom prst="rect">
             <a:avLst/>
@@ -2057,6 +2057,45 @@
       <p:sp>
         <p:nvSpPr>
           <p:cNvPr id="3" name="Text 1"/>
+          <p:cNvSpPr txBox="1"/>
+          <p:nvPr/>
+        </p:nvSpPr>
+        <p:spPr>
+          <a:xfrm>
+            <a:off x="9722815" y="566928"/>
+            <a:ext cx="1828800" cy="274320"/>
+          </a:xfrm>
+          <a:prstGeom prst="rect">
+            <a:avLst/>
+          </a:prstGeom>
+          <a:noFill/>
+          <a:ln/>
+        </p:spPr>
+        <p:txBody>
+          <a:bodyPr wrap="square" lIns="0" tIns="0" rIns="0" bIns="0" rtlCol="0" anchor="ctr"/>
+          <a:lstStyle/>
+          <a:p>
+            <a:pPr algn="r" indent="0" marL="0">
+              <a:buNone/>
+            </a:pPr>
+            <a:r>
+              <a:rPr lang="en-US" sz="1200" dirty="0">
+                <a:solidFill>
+                  <a:srgbClr val="9CA3AF"/>
+                </a:solidFill>
+                <a:latin typeface="Arial" pitchFamily="34" charset="0"/>
+                <a:ea typeface="Arial" pitchFamily="34" charset="-122"/>
+                <a:cs typeface="Arial" pitchFamily="34" charset="-120"/>
+              </a:rPr>
+              <a:t>10 / 11</a:t>
+            </a:r>
+            <a:endParaRPr lang="en-US" sz="1200" dirty="0"/>
+          </a:p>
+        </p:txBody>
+      </p:sp>
+      <p:sp>
+        <p:nvSpPr>
+          <p:cNvPr id="4" name="Text 2"/>
           <p:cNvSpPr txBox="1"/>
           <p:nvPr/>
         </p:nvSpPr>
@@ -2150,7 +2189,7 @@
       </p:sp>
       <p:pic>
         <p:nvPicPr>
-          <p:cNvPr id="4" name="Image 0" descr="/home/user/ges-2/docs/strategy/deck-images/platforms.jpg">    </p:cNvPr>
+          <p:cNvPr id="5" name="Image 0" descr="/home/user/ges-2/docs/strategy/deck-images/platforms.jpg">    </p:cNvPr>
           <p:cNvPicPr>
             <a:picLocks noChangeAspect="1"/>
           </p:cNvPicPr>
@@ -2174,7 +2213,7 @@
       </p:pic>
       <p:sp>
         <p:nvSpPr>
-          <p:cNvPr id="5" name="Shape 2"/>
+          <p:cNvPr id="6" name="Shape 3"/>
           <p:cNvSpPr/>
           <p:nvPr/>
         </p:nvSpPr>
@@ -2228,7 +2267,7 @@
         <p:spPr>
           <a:xfrm>
             <a:off x="640080" y="457200"/>
-            <a:ext cx="10911535" cy="731520"/>
+            <a:ext cx="9144000" cy="731520"/>
           </a:xfrm>
           <a:prstGeom prst="rect">
             <a:avLst/>
@@ -2266,6 +2305,45 @@
         </p:nvSpPr>
         <p:spPr>
           <a:xfrm>
+            <a:off x="9722815" y="566928"/>
+            <a:ext cx="1828800" cy="274320"/>
+          </a:xfrm>
+          <a:prstGeom prst="rect">
+            <a:avLst/>
+          </a:prstGeom>
+          <a:noFill/>
+          <a:ln/>
+        </p:spPr>
+        <p:txBody>
+          <a:bodyPr wrap="square" lIns="0" tIns="0" rIns="0" bIns="0" rtlCol="0" anchor="ctr"/>
+          <a:lstStyle/>
+          <a:p>
+            <a:pPr algn="r" indent="0" marL="0">
+              <a:buNone/>
+            </a:pPr>
+            <a:r>
+              <a:rPr lang="en-US" sz="1200" dirty="0">
+                <a:solidFill>
+                  <a:srgbClr val="9CA3AF"/>
+                </a:solidFill>
+                <a:latin typeface="Arial" pitchFamily="34" charset="0"/>
+                <a:ea typeface="Arial" pitchFamily="34" charset="-122"/>
+                <a:cs typeface="Arial" pitchFamily="34" charset="-120"/>
+              </a:rPr>
+              <a:t>11 / 11</a:t>
+            </a:r>
+            <a:endParaRPr lang="en-US" sz="1200" dirty="0"/>
+          </a:p>
+        </p:txBody>
+      </p:sp>
+      <p:sp>
+        <p:nvSpPr>
+          <p:cNvPr id="4" name="Text 2"/>
+          <p:cNvSpPr txBox="1"/>
+          <p:nvPr/>
+        </p:nvSpPr>
+        <p:spPr>
+          <a:xfrm>
             <a:off x="640080" y="1783080"/>
             <a:ext cx="3474720" cy="320040"/>
           </a:xfrm>
@@ -2299,7 +2377,7 @@
       </p:sp>
       <p:sp>
         <p:nvSpPr>
-          <p:cNvPr id="4" name="Text 2"/>
+          <p:cNvPr id="5" name="Text 3"/>
           <p:cNvSpPr txBox="1"/>
           <p:nvPr/>
         </p:nvSpPr>
@@ -2369,7 +2447,7 @@
       </p:sp>
       <p:sp>
         <p:nvSpPr>
-          <p:cNvPr id="5" name="Text 3"/>
+          <p:cNvPr id="6" name="Text 4"/>
           <p:cNvSpPr txBox="1"/>
           <p:nvPr/>
         </p:nvSpPr>
@@ -2408,7 +2486,7 @@
       </p:sp>
       <p:sp>
         <p:nvSpPr>
-          <p:cNvPr id="6" name="Text 4"/>
+          <p:cNvPr id="7" name="Text 5"/>
           <p:cNvSpPr txBox="1"/>
           <p:nvPr/>
         </p:nvSpPr>
@@ -2550,7 +2628,7 @@
       </p:sp>
       <p:pic>
         <p:nvPicPr>
-          <p:cNvPr id="7" name="Image 0" descr="/home/user/ges-2/docs/strategy/deck-images/books.jpg">    </p:cNvPr>
+          <p:cNvPr id="8" name="Image 0" descr="/home/user/ges-2/docs/strategy/deck-images/books.jpg">    </p:cNvPr>
           <p:cNvPicPr>
             <a:picLocks noChangeAspect="1"/>
           </p:cNvPicPr>
@@ -2574,7 +2652,7 @@
       </p:pic>
       <p:sp>
         <p:nvSpPr>
-          <p:cNvPr id="8" name="Shape 5"/>
+          <p:cNvPr id="9" name="Shape 6"/>
           <p:cNvSpPr/>
           <p:nvPr/>
         </p:nvSpPr>
@@ -2628,7 +2706,7 @@
         <p:spPr>
           <a:xfrm>
             <a:off x="640080" y="457200"/>
-            <a:ext cx="10911535" cy="731520"/>
+            <a:ext cx="9144000" cy="731520"/>
           </a:xfrm>
           <a:prstGeom prst="rect">
             <a:avLst/>
@@ -2661,6 +2739,45 @@
       <p:sp>
         <p:nvSpPr>
           <p:cNvPr id="3" name="Text 1"/>
+          <p:cNvSpPr txBox="1"/>
+          <p:nvPr/>
+        </p:nvSpPr>
+        <p:spPr>
+          <a:xfrm>
+            <a:off x="9722815" y="566928"/>
+            <a:ext cx="1828800" cy="274320"/>
+          </a:xfrm>
+          <a:prstGeom prst="rect">
+            <a:avLst/>
+          </a:prstGeom>
+          <a:noFill/>
+          <a:ln/>
+        </p:spPr>
+        <p:txBody>
+          <a:bodyPr wrap="square" lIns="0" tIns="0" rIns="0" bIns="0" rtlCol="0" anchor="ctr"/>
+          <a:lstStyle/>
+          <a:p>
+            <a:pPr algn="r" indent="0" marL="0">
+              <a:buNone/>
+            </a:pPr>
+            <a:r>
+              <a:rPr lang="en-US" sz="1200" dirty="0">
+                <a:solidFill>
+                  <a:srgbClr val="9CA3AF"/>
+                </a:solidFill>
+                <a:latin typeface="Arial" pitchFamily="34" charset="0"/>
+                <a:ea typeface="Arial" pitchFamily="34" charset="-122"/>
+                <a:cs typeface="Arial" pitchFamily="34" charset="-120"/>
+              </a:rPr>
+              <a:t>2 / 11</a:t>
+            </a:r>
+            <a:endParaRPr lang="en-US" sz="1200" dirty="0"/>
+          </a:p>
+        </p:txBody>
+      </p:sp>
+      <p:sp>
+        <p:nvSpPr>
+          <p:cNvPr id="4" name="Text 2"/>
           <p:cNvSpPr txBox="1"/>
           <p:nvPr/>
         </p:nvSpPr>
@@ -2714,7 +2831,7 @@
                 <a:ea typeface="Arial" pitchFamily="34" charset="-122"/>
                 <a:cs typeface="Arial" pitchFamily="34" charset="-120"/>
               </a:rPr>
-              <a:t>ради чего существует сервис</a:t>
+              <a:t>что поддерживает сервис</a:t>
             </a:r>
             <a:endParaRPr lang="en-US" sz="1800" dirty="0"/>
           </a:p>
@@ -2722,7 +2839,7 @@
       </p:sp>
       <p:sp>
         <p:nvSpPr>
-          <p:cNvPr id="4" name="Shape 2"/>
+          <p:cNvPr id="5" name="Shape 3"/>
           <p:cNvSpPr/>
           <p:nvPr/>
         </p:nvSpPr>
@@ -2745,7 +2862,7 @@
       </p:sp>
       <p:sp>
         <p:nvSpPr>
-          <p:cNvPr id="5" name="Text 3"/>
+          <p:cNvPr id="6" name="Text 4"/>
           <p:cNvSpPr txBox="1"/>
           <p:nvPr/>
         </p:nvSpPr>
@@ -2779,7 +2896,7 @@
                 <a:ea typeface="Arial" pitchFamily="34" charset="-122"/>
                 <a:cs typeface="Arial" pitchFamily="34" charset="-120"/>
               </a:rPr>
-              <a:t>Сервис не создаёт доверие,</a:t>
+              <a:t>Исполнение сервиса требует</a:t>
             </a:r>
             <a:endParaRPr lang="en-US" sz="1800" dirty="0"/>
           </a:p>
@@ -2799,7 +2916,7 @@
                 <a:ea typeface="Arial" pitchFamily="34" charset="-122"/>
                 <a:cs typeface="Arial" pitchFamily="34" charset="-120"/>
               </a:rPr>
-              <a:t>он его исполняет и конвертирует</a:t>
+              <a:t>единых стандартов и дисциплины</a:t>
             </a:r>
             <a:endParaRPr lang="en-US" sz="1800" dirty="0"/>
           </a:p>
@@ -2807,7 +2924,7 @@
       </p:sp>
       <p:sp>
         <p:nvSpPr>
-          <p:cNvPr id="6" name="Shape 4"/>
+          <p:cNvPr id="7" name="Shape 5"/>
           <p:cNvSpPr/>
           <p:nvPr/>
         </p:nvSpPr>
@@ -2830,7 +2947,7 @@
       </p:sp>
       <p:sp>
         <p:nvSpPr>
-          <p:cNvPr id="7" name="Text 5"/>
+          <p:cNvPr id="8" name="Text 6"/>
           <p:cNvSpPr txBox="1"/>
           <p:nvPr/>
         </p:nvSpPr>
@@ -2864,7 +2981,7 @@
                 <a:ea typeface="Arial" pitchFamily="34" charset="-122"/>
                 <a:cs typeface="Arial" pitchFamily="34" charset="-120"/>
               </a:rPr>
-              <a:t>Периметр - весь путь, от поиска</a:t>
+              <a:t>Постепенный переход к модели</a:t>
             </a:r>
             <a:endParaRPr lang="en-US" sz="1800" dirty="0"/>
           </a:p>
@@ -2884,7 +3001,7 @@
                 <a:ea typeface="Arial" pitchFamily="34" charset="-122"/>
                 <a:cs typeface="Arial" pitchFamily="34" charset="-120"/>
               </a:rPr>
-              <a:t>информации до выхода из здания</a:t>
+              <a:t>частичной окупаемости находится в фокусе</a:t>
             </a:r>
             <a:endParaRPr lang="en-US" sz="1800" dirty="0"/>
           </a:p>
@@ -2892,7 +3009,7 @@
       </p:sp>
       <p:pic>
         <p:nvPicPr>
-          <p:cNvPr id="8" name="Image 0" descr="/home/user/ges-2/docs/strategy/deck-images/facade.jpg">    </p:cNvPr>
+          <p:cNvPr id="9" name="Image 0" descr="/home/user/ges-2/docs/strategy/deck-images/facade.jpg">    </p:cNvPr>
           <p:cNvPicPr>
             <a:picLocks noChangeAspect="1"/>
           </p:cNvPicPr>
@@ -2916,7 +3033,7 @@
       </p:pic>
       <p:sp>
         <p:nvSpPr>
-          <p:cNvPr id="9" name="Shape 6"/>
+          <p:cNvPr id="10" name="Shape 7"/>
           <p:cNvSpPr/>
           <p:nvPr/>
         </p:nvSpPr>
@@ -2970,7 +3087,7 @@
         <p:spPr>
           <a:xfrm>
             <a:off x="640080" y="457200"/>
-            <a:ext cx="10911535" cy="731520"/>
+            <a:ext cx="9144000" cy="731520"/>
           </a:xfrm>
           <a:prstGeom prst="rect">
             <a:avLst/>
@@ -3008,6 +3125,45 @@
         </p:nvSpPr>
         <p:spPr>
           <a:xfrm>
+            <a:off x="9722815" y="566928"/>
+            <a:ext cx="1828800" cy="274320"/>
+          </a:xfrm>
+          <a:prstGeom prst="rect">
+            <a:avLst/>
+          </a:prstGeom>
+          <a:noFill/>
+          <a:ln/>
+        </p:spPr>
+        <p:txBody>
+          <a:bodyPr wrap="square" lIns="0" tIns="0" rIns="0" bIns="0" rtlCol="0" anchor="ctr"/>
+          <a:lstStyle/>
+          <a:p>
+            <a:pPr algn="r" indent="0" marL="0">
+              <a:buNone/>
+            </a:pPr>
+            <a:r>
+              <a:rPr lang="en-US" sz="1200" dirty="0">
+                <a:solidFill>
+                  <a:srgbClr val="9CA3AF"/>
+                </a:solidFill>
+                <a:latin typeface="Arial" pitchFamily="34" charset="0"/>
+                <a:ea typeface="Arial" pitchFamily="34" charset="-122"/>
+                <a:cs typeface="Arial" pitchFamily="34" charset="-120"/>
+              </a:rPr>
+              <a:t>3 / 11</a:t>
+            </a:r>
+            <a:endParaRPr lang="en-US" sz="1200" dirty="0"/>
+          </a:p>
+        </p:txBody>
+      </p:sp>
+      <p:sp>
+        <p:nvSpPr>
+          <p:cNvPr id="4" name="Text 2"/>
+          <p:cNvSpPr txBox="1"/>
+          <p:nvPr/>
+        </p:nvSpPr>
+        <p:spPr>
+          <a:xfrm>
             <a:off x="640080" y="1737360"/>
             <a:ext cx="548640" cy="365760"/>
           </a:xfrm>
@@ -3041,7 +3197,7 @@
       </p:sp>
       <p:sp>
         <p:nvSpPr>
-          <p:cNvPr id="4" name="Text 2"/>
+          <p:cNvPr id="5" name="Text 3"/>
           <p:cNvSpPr txBox="1"/>
           <p:nvPr/>
         </p:nvSpPr>
@@ -3072,7 +3228,7 @@
                 <a:ea typeface="Arial" pitchFamily="34" charset="-122"/>
                 <a:cs typeface="Arial" pitchFamily="34" charset="-120"/>
               </a:rPr>
-              <a:t>Горизонтальные связи</a:t>
+              <a:t>Как выстраивается взаимодействие</a:t>
             </a:r>
             <a:endParaRPr lang="en-US" sz="1600" dirty="0"/>
           </a:p>
@@ -3080,7 +3236,7 @@
       </p:sp>
       <p:sp>
         <p:nvSpPr>
-          <p:cNvPr id="5" name="Shape 3"/>
+          <p:cNvPr id="6" name="Shape 4"/>
           <p:cNvSpPr/>
           <p:nvPr/>
         </p:nvSpPr>
@@ -3103,7 +3259,7 @@
       </p:sp>
       <p:sp>
         <p:nvSpPr>
-          <p:cNvPr id="6" name="Text 4"/>
+          <p:cNvPr id="7" name="Text 5"/>
           <p:cNvSpPr txBox="1"/>
           <p:nvPr/>
         </p:nvSpPr>
@@ -3142,7 +3298,7 @@
       </p:sp>
       <p:sp>
         <p:nvSpPr>
-          <p:cNvPr id="7" name="Text 5"/>
+          <p:cNvPr id="8" name="Text 6"/>
           <p:cNvSpPr txBox="1"/>
           <p:nvPr/>
         </p:nvSpPr>
@@ -3181,7 +3337,7 @@
       </p:sp>
       <p:sp>
         <p:nvSpPr>
-          <p:cNvPr id="8" name="Shape 6"/>
+          <p:cNvPr id="9" name="Shape 7"/>
           <p:cNvSpPr/>
           <p:nvPr/>
         </p:nvSpPr>
@@ -3204,7 +3360,7 @@
       </p:sp>
       <p:sp>
         <p:nvSpPr>
-          <p:cNvPr id="9" name="Text 7"/>
+          <p:cNvPr id="10" name="Text 8"/>
           <p:cNvSpPr txBox="1"/>
           <p:nvPr/>
         </p:nvSpPr>
@@ -3243,7 +3399,7 @@
       </p:sp>
       <p:sp>
         <p:nvSpPr>
-          <p:cNvPr id="10" name="Text 8"/>
+          <p:cNvPr id="11" name="Text 9"/>
           <p:cNvSpPr txBox="1"/>
           <p:nvPr/>
         </p:nvSpPr>
@@ -3282,7 +3438,7 @@
       </p:sp>
       <p:sp>
         <p:nvSpPr>
-          <p:cNvPr id="11" name="Shape 9"/>
+          <p:cNvPr id="12" name="Shape 10"/>
           <p:cNvSpPr/>
           <p:nvPr/>
         </p:nvSpPr>
@@ -3305,7 +3461,7 @@
       </p:sp>
       <p:sp>
         <p:nvSpPr>
-          <p:cNvPr id="12" name="Text 10"/>
+          <p:cNvPr id="13" name="Text 11"/>
           <p:cNvSpPr txBox="1"/>
           <p:nvPr/>
         </p:nvSpPr>
@@ -3344,7 +3500,7 @@
       </p:sp>
       <p:sp>
         <p:nvSpPr>
-          <p:cNvPr id="13" name="Text 11"/>
+          <p:cNvPr id="14" name="Text 12"/>
           <p:cNvSpPr txBox="1"/>
           <p:nvPr/>
         </p:nvSpPr>
@@ -3383,7 +3539,7 @@
       </p:sp>
       <p:sp>
         <p:nvSpPr>
-          <p:cNvPr id="14" name="Shape 12"/>
+          <p:cNvPr id="15" name="Shape 13"/>
           <p:cNvSpPr/>
           <p:nvPr/>
         </p:nvSpPr>
@@ -3406,7 +3562,7 @@
       </p:sp>
       <p:sp>
         <p:nvSpPr>
-          <p:cNvPr id="15" name="Text 13"/>
+          <p:cNvPr id="16" name="Text 14"/>
           <p:cNvSpPr txBox="1"/>
           <p:nvPr/>
         </p:nvSpPr>
@@ -3445,7 +3601,7 @@
       </p:sp>
       <p:sp>
         <p:nvSpPr>
-          <p:cNvPr id="16" name="Text 14"/>
+          <p:cNvPr id="17" name="Text 15"/>
           <p:cNvSpPr txBox="1"/>
           <p:nvPr/>
         </p:nvSpPr>
@@ -3484,7 +3640,7 @@
       </p:sp>
       <p:sp>
         <p:nvSpPr>
-          <p:cNvPr id="17" name="Shape 15"/>
+          <p:cNvPr id="18" name="Shape 16"/>
           <p:cNvSpPr/>
           <p:nvPr/>
         </p:nvSpPr>
@@ -3507,7 +3663,7 @@
       </p:sp>
       <p:sp>
         <p:nvSpPr>
-          <p:cNvPr id="18" name="Text 16"/>
+          <p:cNvPr id="19" name="Text 17"/>
           <p:cNvSpPr txBox="1"/>
           <p:nvPr/>
         </p:nvSpPr>
@@ -3546,7 +3702,7 @@
       </p:sp>
       <p:sp>
         <p:nvSpPr>
-          <p:cNvPr id="19" name="Text 17"/>
+          <p:cNvPr id="20" name="Text 18"/>
           <p:cNvSpPr txBox="1"/>
           <p:nvPr/>
         </p:nvSpPr>
@@ -3585,7 +3741,7 @@
       </p:sp>
       <p:sp>
         <p:nvSpPr>
-          <p:cNvPr id="20" name="Shape 18"/>
+          <p:cNvPr id="21" name="Shape 19"/>
           <p:cNvSpPr/>
           <p:nvPr/>
         </p:nvSpPr>
@@ -3608,7 +3764,7 @@
       </p:sp>
       <p:sp>
         <p:nvSpPr>
-          <p:cNvPr id="21" name="Text 19"/>
+          <p:cNvPr id="22" name="Text 20"/>
           <p:cNvSpPr txBox="1"/>
           <p:nvPr/>
         </p:nvSpPr>
@@ -3647,7 +3803,7 @@
       </p:sp>
       <p:sp>
         <p:nvSpPr>
-          <p:cNvPr id="22" name="Text 20"/>
+          <p:cNvPr id="23" name="Text 21"/>
           <p:cNvSpPr txBox="1"/>
           <p:nvPr/>
         </p:nvSpPr>
@@ -3686,7 +3842,7 @@
       </p:sp>
       <p:sp>
         <p:nvSpPr>
-          <p:cNvPr id="23" name="Shape 21"/>
+          <p:cNvPr id="24" name="Shape 22"/>
           <p:cNvSpPr/>
           <p:nvPr/>
         </p:nvSpPr>
@@ -3709,7 +3865,7 @@
       </p:sp>
       <p:sp>
         <p:nvSpPr>
-          <p:cNvPr id="24" name="Text 22"/>
+          <p:cNvPr id="25" name="Text 23"/>
           <p:cNvSpPr txBox="1"/>
           <p:nvPr/>
         </p:nvSpPr>
@@ -3748,7 +3904,7 @@
       </p:sp>
       <p:sp>
         <p:nvSpPr>
-          <p:cNvPr id="25" name="Text 23"/>
+          <p:cNvPr id="26" name="Text 24"/>
           <p:cNvSpPr txBox="1"/>
           <p:nvPr/>
         </p:nvSpPr>
@@ -3787,7 +3943,7 @@
       </p:sp>
       <p:sp>
         <p:nvSpPr>
-          <p:cNvPr id="26" name="Shape 24"/>
+          <p:cNvPr id="27" name="Shape 25"/>
           <p:cNvSpPr/>
           <p:nvPr/>
         </p:nvSpPr>
@@ -3810,7 +3966,7 @@
       </p:sp>
       <p:pic>
         <p:nvPicPr>
-          <p:cNvPr id="27" name="Image 0" descr="/home/user/ges-2/docs/strategy/deck-images/prospekt.jpg">    </p:cNvPr>
+          <p:cNvPr id="28" name="Image 0" descr="/home/user/ges-2/docs/strategy/deck-images/prospekt.jpg">    </p:cNvPr>
           <p:cNvPicPr>
             <a:picLocks noChangeAspect="1"/>
           </p:cNvPicPr>
@@ -3834,7 +3990,7 @@
       </p:pic>
       <p:sp>
         <p:nvSpPr>
-          <p:cNvPr id="28" name="Shape 25"/>
+          <p:cNvPr id="29" name="Shape 26"/>
           <p:cNvSpPr/>
           <p:nvPr/>
         </p:nvSpPr>
@@ -3888,7 +4044,7 @@
         <p:spPr>
           <a:xfrm>
             <a:off x="640080" y="457200"/>
-            <a:ext cx="10911535" cy="731520"/>
+            <a:ext cx="9144000" cy="731520"/>
           </a:xfrm>
           <a:prstGeom prst="rect">
             <a:avLst/>
@@ -3915,12 +4071,51 @@
               <a:t>Как выстраивается взаимодействие</a:t>
             </a:r>
             <a:endParaRPr lang="en-US" sz="3000" dirty="0"/>
+          </a:p>
+        </p:txBody>
+      </p:sp>
+      <p:sp>
+        <p:nvSpPr>
+          <p:cNvPr id="3" name="Text 1"/>
+          <p:cNvSpPr txBox="1"/>
+          <p:nvPr/>
+        </p:nvSpPr>
+        <p:spPr>
+          <a:xfrm>
+            <a:off x="9722815" y="566928"/>
+            <a:ext cx="1828800" cy="274320"/>
+          </a:xfrm>
+          <a:prstGeom prst="rect">
+            <a:avLst/>
+          </a:prstGeom>
+          <a:noFill/>
+          <a:ln/>
+        </p:spPr>
+        <p:txBody>
+          <a:bodyPr wrap="square" lIns="0" tIns="0" rIns="0" bIns="0" rtlCol="0" anchor="ctr"/>
+          <a:lstStyle/>
+          <a:p>
+            <a:pPr algn="r" indent="0" marL="0">
+              <a:buNone/>
+            </a:pPr>
+            <a:r>
+              <a:rPr lang="en-US" sz="1200" dirty="0">
+                <a:solidFill>
+                  <a:srgbClr val="9CA3AF"/>
+                </a:solidFill>
+                <a:latin typeface="Arial" pitchFamily="34" charset="0"/>
+                <a:ea typeface="Arial" pitchFamily="34" charset="-122"/>
+                <a:cs typeface="Arial" pitchFamily="34" charset="-120"/>
+              </a:rPr>
+              <a:t>4 / 11</a:t>
+            </a:r>
+            <a:endParaRPr lang="en-US" sz="1200" dirty="0"/>
           </a:p>
         </p:txBody>
       </p:sp>
       <p:pic>
         <p:nvPicPr>
-          <p:cNvPr id="3" name="Image 0" descr="/home/user/ges-2/docs/strategy/deck-images/svody.jpg">    </p:cNvPr>
+          <p:cNvPr id="4" name="Image 0" descr="/home/user/ges-2/docs/strategy/deck-images/svody.jpg">    </p:cNvPr>
           <p:cNvPicPr>
             <a:picLocks noChangeAspect="1"/>
           </p:cNvPicPr>
@@ -3944,7 +4139,7 @@
       </p:pic>
       <p:sp>
         <p:nvSpPr>
-          <p:cNvPr id="4" name="Shape 1"/>
+          <p:cNvPr id="5" name="Shape 2"/>
           <p:cNvSpPr/>
           <p:nvPr/>
         </p:nvSpPr>
@@ -3966,7 +4161,7 @@
       </p:sp>
       <p:sp>
         <p:nvSpPr>
-          <p:cNvPr id="5" name="Text 2"/>
+          <p:cNvPr id="6" name="Text 3"/>
           <p:cNvSpPr txBox="1"/>
           <p:nvPr/>
         </p:nvSpPr>
@@ -4140,7 +4335,7 @@
         <p:spPr>
           <a:xfrm>
             <a:off x="640080" y="457200"/>
-            <a:ext cx="10911535" cy="731520"/>
+            <a:ext cx="9144000" cy="731520"/>
           </a:xfrm>
           <a:prstGeom prst="rect">
             <a:avLst/>
@@ -4178,6 +4373,45 @@
         </p:nvSpPr>
         <p:spPr>
           <a:xfrm>
+            <a:off x="9722815" y="566928"/>
+            <a:ext cx="1828800" cy="274320"/>
+          </a:xfrm>
+          <a:prstGeom prst="rect">
+            <a:avLst/>
+          </a:prstGeom>
+          <a:noFill/>
+          <a:ln/>
+        </p:spPr>
+        <p:txBody>
+          <a:bodyPr wrap="square" lIns="0" tIns="0" rIns="0" bIns="0" rtlCol="0" anchor="ctr"/>
+          <a:lstStyle/>
+          <a:p>
+            <a:pPr algn="r" indent="0" marL="0">
+              <a:buNone/>
+            </a:pPr>
+            <a:r>
+              <a:rPr lang="en-US" sz="1200" dirty="0">
+                <a:solidFill>
+                  <a:srgbClr val="9CA3AF"/>
+                </a:solidFill>
+                <a:latin typeface="Arial" pitchFamily="34" charset="0"/>
+                <a:ea typeface="Arial" pitchFamily="34" charset="-122"/>
+                <a:cs typeface="Arial" pitchFamily="34" charset="-120"/>
+              </a:rPr>
+              <a:t>5 / 11</a:t>
+            </a:r>
+            <a:endParaRPr lang="en-US" sz="1200" dirty="0"/>
+          </a:p>
+        </p:txBody>
+      </p:sp>
+      <p:sp>
+        <p:nvSpPr>
+          <p:cNvPr id="4" name="Text 2"/>
+          <p:cNvSpPr txBox="1"/>
+          <p:nvPr/>
+        </p:nvSpPr>
+        <p:spPr>
+          <a:xfrm>
             <a:off x="640080" y="1837944"/>
             <a:ext cx="457200" cy="457200"/>
           </a:xfrm>
@@ -4211,7 +4445,7 @@
       </p:sp>
       <p:sp>
         <p:nvSpPr>
-          <p:cNvPr id="4" name="Text 2"/>
+          <p:cNvPr id="5" name="Text 3"/>
           <p:cNvSpPr txBox="1"/>
           <p:nvPr/>
         </p:nvSpPr>
@@ -4253,7 +4487,7 @@
       </p:sp>
       <p:sp>
         <p:nvSpPr>
-          <p:cNvPr id="5" name="Text 3"/>
+          <p:cNvPr id="6" name="Text 4"/>
           <p:cNvSpPr txBox="1"/>
           <p:nvPr/>
         </p:nvSpPr>
@@ -4292,7 +4526,7 @@
       </p:sp>
       <p:sp>
         <p:nvSpPr>
-          <p:cNvPr id="6" name="Text 4"/>
+          <p:cNvPr id="7" name="Text 5"/>
           <p:cNvSpPr txBox="1"/>
           <p:nvPr/>
         </p:nvSpPr>
@@ -4334,7 +4568,7 @@
       </p:sp>
       <p:sp>
         <p:nvSpPr>
-          <p:cNvPr id="7" name="Text 5"/>
+          <p:cNvPr id="8" name="Text 6"/>
           <p:cNvSpPr txBox="1"/>
           <p:nvPr/>
         </p:nvSpPr>
@@ -4373,7 +4607,7 @@
       </p:sp>
       <p:sp>
         <p:nvSpPr>
-          <p:cNvPr id="8" name="Text 6"/>
+          <p:cNvPr id="9" name="Text 7"/>
           <p:cNvSpPr txBox="1"/>
           <p:nvPr/>
         </p:nvSpPr>
@@ -4415,7 +4649,7 @@
       </p:sp>
       <p:sp>
         <p:nvSpPr>
-          <p:cNvPr id="9" name="Text 7"/>
+          <p:cNvPr id="10" name="Text 8"/>
           <p:cNvSpPr txBox="1"/>
           <p:nvPr/>
         </p:nvSpPr>
@@ -4454,7 +4688,7 @@
       </p:sp>
       <p:sp>
         <p:nvSpPr>
-          <p:cNvPr id="10" name="Text 8"/>
+          <p:cNvPr id="11" name="Text 9"/>
           <p:cNvSpPr txBox="1"/>
           <p:nvPr/>
         </p:nvSpPr>
@@ -4496,7 +4730,7 @@
       </p:sp>
       <p:sp>
         <p:nvSpPr>
-          <p:cNvPr id="11" name="Text 9"/>
+          <p:cNvPr id="12" name="Text 10"/>
           <p:cNvSpPr txBox="1"/>
           <p:nvPr/>
         </p:nvSpPr>
@@ -4535,7 +4769,7 @@
       </p:sp>
       <p:sp>
         <p:nvSpPr>
-          <p:cNvPr id="12" name="Text 10"/>
+          <p:cNvPr id="13" name="Text 11"/>
           <p:cNvSpPr txBox="1"/>
           <p:nvPr/>
         </p:nvSpPr>
@@ -4577,7 +4811,7 @@
       </p:sp>
       <p:pic>
         <p:nvPicPr>
-          <p:cNvPr id="13" name="Image 0" descr="/home/user/ges-2/docs/strategy/deck-images/flow.jpg">    </p:cNvPr>
+          <p:cNvPr id="14" name="Image 0" descr="/home/user/ges-2/docs/strategy/deck-images/flow.jpg">    </p:cNvPr>
           <p:cNvPicPr>
             <a:picLocks noChangeAspect="1"/>
           </p:cNvPicPr>
@@ -4601,7 +4835,7 @@
       </p:pic>
       <p:sp>
         <p:nvSpPr>
-          <p:cNvPr id="14" name="Shape 11"/>
+          <p:cNvPr id="15" name="Shape 12"/>
           <p:cNvSpPr/>
           <p:nvPr/>
         </p:nvSpPr>
@@ -4655,7 +4889,7 @@
         <p:spPr>
           <a:xfrm>
             <a:off x="640080" y="457200"/>
-            <a:ext cx="10911535" cy="731520"/>
+            <a:ext cx="9144000" cy="731520"/>
           </a:xfrm>
           <a:prstGeom prst="rect">
             <a:avLst/>
@@ -4682,6 +4916,45 @@
               <a:t>Обратная связь и метрики</a:t>
             </a:r>
             <a:endParaRPr lang="en-US" sz="3000" dirty="0"/>
+          </a:p>
+        </p:txBody>
+      </p:sp>
+      <p:sp>
+        <p:nvSpPr>
+          <p:cNvPr id="3" name="Text 1"/>
+          <p:cNvSpPr txBox="1"/>
+          <p:nvPr/>
+        </p:nvSpPr>
+        <p:spPr>
+          <a:xfrm>
+            <a:off x="9722815" y="566928"/>
+            <a:ext cx="1828800" cy="274320"/>
+          </a:xfrm>
+          <a:prstGeom prst="rect">
+            <a:avLst/>
+          </a:prstGeom>
+          <a:noFill/>
+          <a:ln/>
+        </p:spPr>
+        <p:txBody>
+          <a:bodyPr wrap="square" lIns="0" tIns="0" rIns="0" bIns="0" rtlCol="0" anchor="ctr"/>
+          <a:lstStyle/>
+          <a:p>
+            <a:pPr algn="r" indent="0" marL="0">
+              <a:buNone/>
+            </a:pPr>
+            <a:r>
+              <a:rPr lang="en-US" sz="1200" dirty="0">
+                <a:solidFill>
+                  <a:srgbClr val="9CA3AF"/>
+                </a:solidFill>
+                <a:latin typeface="Arial" pitchFamily="34" charset="0"/>
+                <a:ea typeface="Arial" pitchFamily="34" charset="-122"/>
+                <a:cs typeface="Arial" pitchFamily="34" charset="-120"/>
+              </a:rPr>
+              <a:t>6 / 11</a:t>
+            </a:r>
+            <a:endParaRPr lang="en-US" sz="1200" dirty="0"/>
           </a:p>
         </p:txBody>
       </p:sp>
@@ -5719,7 +5992,7 @@
       </p:graphicFrame>
       <p:sp>
         <p:nvSpPr>
-          <p:cNvPr id="4" name="Shape 1"/>
+          <p:cNvPr id="5" name="Shape 2"/>
           <p:cNvSpPr/>
           <p:nvPr/>
         </p:nvSpPr>
@@ -5742,7 +6015,7 @@
       </p:sp>
       <p:sp>
         <p:nvSpPr>
-          <p:cNvPr id="5" name="Text 2"/>
+          <p:cNvPr id="6" name="Text 3"/>
           <p:cNvSpPr txBox="1"/>
           <p:nvPr/>
         </p:nvSpPr>
@@ -5804,7 +6077,7 @@
       </p:sp>
       <p:sp>
         <p:nvSpPr>
-          <p:cNvPr id="6" name="Text 3"/>
+          <p:cNvPr id="7" name="Text 4"/>
           <p:cNvSpPr txBox="1"/>
           <p:nvPr/>
         </p:nvSpPr>
@@ -5858,7 +6131,7 @@
                 <a:ea typeface="Arial" pitchFamily="34" charset="-122"/>
                 <a:cs typeface="Arial" pitchFamily="34" charset="-120"/>
               </a:rPr>
-              <a:t>раз в год</a:t>
+              <a:t>несколько раз в год</a:t>
             </a:r>
             <a:endParaRPr lang="en-US" sz="1300" dirty="0"/>
           </a:p>
@@ -5866,7 +6139,7 @@
       </p:sp>
       <p:sp>
         <p:nvSpPr>
-          <p:cNvPr id="7" name="Text 4"/>
+          <p:cNvPr id="8" name="Text 5"/>
           <p:cNvSpPr txBox="1"/>
           <p:nvPr/>
         </p:nvSpPr>
@@ -5960,7 +6233,7 @@
         <p:spPr>
           <a:xfrm>
             <a:off x="640080" y="457200"/>
-            <a:ext cx="10911535" cy="731520"/>
+            <a:ext cx="9144000" cy="731520"/>
           </a:xfrm>
           <a:prstGeom prst="rect">
             <a:avLst/>
@@ -5987,12 +6260,51 @@
               <a:t>Персонал и гостеприимство</a:t>
             </a:r>
             <a:endParaRPr lang="en-US" sz="3000" dirty="0"/>
+          </a:p>
+        </p:txBody>
+      </p:sp>
+      <p:sp>
+        <p:nvSpPr>
+          <p:cNvPr id="3" name="Text 1"/>
+          <p:cNvSpPr txBox="1"/>
+          <p:nvPr/>
+        </p:nvSpPr>
+        <p:spPr>
+          <a:xfrm>
+            <a:off x="9722815" y="566928"/>
+            <a:ext cx="1828800" cy="274320"/>
+          </a:xfrm>
+          <a:prstGeom prst="rect">
+            <a:avLst/>
+          </a:prstGeom>
+          <a:noFill/>
+          <a:ln/>
+        </p:spPr>
+        <p:txBody>
+          <a:bodyPr wrap="square" lIns="0" tIns="0" rIns="0" bIns="0" rtlCol="0" anchor="ctr"/>
+          <a:lstStyle/>
+          <a:p>
+            <a:pPr algn="r" indent="0" marL="0">
+              <a:buNone/>
+            </a:pPr>
+            <a:r>
+              <a:rPr lang="en-US" sz="1200" dirty="0">
+                <a:solidFill>
+                  <a:srgbClr val="9CA3AF"/>
+                </a:solidFill>
+                <a:latin typeface="Arial" pitchFamily="34" charset="0"/>
+                <a:ea typeface="Arial" pitchFamily="34" charset="-122"/>
+                <a:cs typeface="Arial" pitchFamily="34" charset="-120"/>
+              </a:rPr>
+              <a:t>7 / 11</a:t>
+            </a:r>
+            <a:endParaRPr lang="en-US" sz="1200" dirty="0"/>
           </a:p>
         </p:txBody>
       </p:sp>
       <p:pic>
         <p:nvPicPr>
-          <p:cNvPr id="3" name="Image 0" descr="/home/user/ges-2/docs/strategy/deck-images/mediation.jpg">    </p:cNvPr>
+          <p:cNvPr id="4" name="Image 0" descr="/home/user/ges-2/docs/strategy/deck-images/mediation.jpg">    </p:cNvPr>
           <p:cNvPicPr>
             <a:picLocks noChangeAspect="1"/>
           </p:cNvPicPr>
@@ -6016,7 +6328,7 @@
       </p:pic>
       <p:sp>
         <p:nvSpPr>
-          <p:cNvPr id="4" name="Shape 1"/>
+          <p:cNvPr id="5" name="Shape 2"/>
           <p:cNvSpPr/>
           <p:nvPr/>
         </p:nvSpPr>
@@ -6038,7 +6350,7 @@
       </p:sp>
       <p:sp>
         <p:nvSpPr>
-          <p:cNvPr id="5" name="Text 2"/>
+          <p:cNvPr id="6" name="Text 3"/>
           <p:cNvSpPr txBox="1"/>
           <p:nvPr/>
         </p:nvSpPr>
@@ -6077,7 +6389,7 @@
       </p:sp>
       <p:sp>
         <p:nvSpPr>
-          <p:cNvPr id="6" name="Text 3"/>
+          <p:cNvPr id="7" name="Text 4"/>
           <p:cNvSpPr txBox="1"/>
           <p:nvPr/>
         </p:nvSpPr>
@@ -6195,7 +6507,7 @@
       </p:sp>
       <p:sp>
         <p:nvSpPr>
-          <p:cNvPr id="7" name="Text 4"/>
+          <p:cNvPr id="8" name="Text 5"/>
           <p:cNvSpPr txBox="1"/>
           <p:nvPr/>
         </p:nvSpPr>
@@ -6234,7 +6546,7 @@
       </p:sp>
       <p:sp>
         <p:nvSpPr>
-          <p:cNvPr id="8" name="Text 5"/>
+          <p:cNvPr id="9" name="Text 6"/>
           <p:cNvSpPr txBox="1"/>
           <p:nvPr/>
         </p:nvSpPr>
@@ -6360,7 +6672,7 @@
         <p:spPr>
           <a:xfrm>
             <a:off x="640080" y="457200"/>
-            <a:ext cx="10911535" cy="731520"/>
+            <a:ext cx="9144000" cy="731520"/>
           </a:xfrm>
           <a:prstGeom prst="rect">
             <a:avLst/>
@@ -6392,7 +6704,46 @@
       </p:sp>
       <p:sp>
         <p:nvSpPr>
-          <p:cNvPr id="3" name="Shape 1"/>
+          <p:cNvPr id="3" name="Text 1"/>
+          <p:cNvSpPr txBox="1"/>
+          <p:nvPr/>
+        </p:nvSpPr>
+        <p:spPr>
+          <a:xfrm>
+            <a:off x="9722815" y="566928"/>
+            <a:ext cx="1828800" cy="274320"/>
+          </a:xfrm>
+          <a:prstGeom prst="rect">
+            <a:avLst/>
+          </a:prstGeom>
+          <a:noFill/>
+          <a:ln/>
+        </p:spPr>
+        <p:txBody>
+          <a:bodyPr wrap="square" lIns="0" tIns="0" rIns="0" bIns="0" rtlCol="0" anchor="ctr"/>
+          <a:lstStyle/>
+          <a:p>
+            <a:pPr algn="r" indent="0" marL="0">
+              <a:buNone/>
+            </a:pPr>
+            <a:r>
+              <a:rPr lang="en-US" sz="1200" dirty="0">
+                <a:solidFill>
+                  <a:srgbClr val="9CA3AF"/>
+                </a:solidFill>
+                <a:latin typeface="Arial" pitchFamily="34" charset="0"/>
+                <a:ea typeface="Arial" pitchFamily="34" charset="-122"/>
+                <a:cs typeface="Arial" pitchFamily="34" charset="-120"/>
+              </a:rPr>
+              <a:t>8 / 11</a:t>
+            </a:r>
+            <a:endParaRPr lang="en-US" sz="1200" dirty="0"/>
+          </a:p>
+        </p:txBody>
+      </p:sp>
+      <p:sp>
+        <p:nvSpPr>
+          <p:cNvPr id="4" name="Shape 2"/>
           <p:cNvSpPr/>
           <p:nvPr/>
         </p:nvSpPr>
@@ -6417,7 +6768,7 @@
       </p:sp>
       <p:sp>
         <p:nvSpPr>
-          <p:cNvPr id="4" name="Text 2"/>
+          <p:cNvPr id="5" name="Text 3"/>
           <p:cNvSpPr txBox="1"/>
           <p:nvPr/>
         </p:nvSpPr>
@@ -6456,7 +6807,7 @@
       </p:sp>
       <p:sp>
         <p:nvSpPr>
-          <p:cNvPr id="5" name="Text 3"/>
+          <p:cNvPr id="6" name="Text 4"/>
           <p:cNvSpPr txBox="1"/>
           <p:nvPr/>
         </p:nvSpPr>
@@ -6518,7 +6869,7 @@
       </p:sp>
       <p:sp>
         <p:nvSpPr>
-          <p:cNvPr id="6" name="Shape 4"/>
+          <p:cNvPr id="7" name="Shape 5"/>
           <p:cNvSpPr/>
           <p:nvPr/>
         </p:nvSpPr>
@@ -6543,7 +6894,7 @@
       </p:sp>
       <p:sp>
         <p:nvSpPr>
-          <p:cNvPr id="7" name="Text 5"/>
+          <p:cNvPr id="8" name="Text 6"/>
           <p:cNvSpPr txBox="1"/>
           <p:nvPr/>
         </p:nvSpPr>
@@ -6582,7 +6933,7 @@
       </p:sp>
       <p:sp>
         <p:nvSpPr>
-          <p:cNvPr id="8" name="Text 6"/>
+          <p:cNvPr id="9" name="Text 7"/>
           <p:cNvSpPr txBox="1"/>
           <p:nvPr/>
         </p:nvSpPr>
@@ -6644,7 +6995,7 @@
       </p:sp>
       <p:sp>
         <p:nvSpPr>
-          <p:cNvPr id="9" name="Shape 7"/>
+          <p:cNvPr id="10" name="Shape 8"/>
           <p:cNvSpPr/>
           <p:nvPr/>
         </p:nvSpPr>
@@ -6669,7 +7020,7 @@
       </p:sp>
       <p:sp>
         <p:nvSpPr>
-          <p:cNvPr id="10" name="Text 8"/>
+          <p:cNvPr id="11" name="Text 9"/>
           <p:cNvSpPr txBox="1"/>
           <p:nvPr/>
         </p:nvSpPr>
@@ -6708,7 +7059,7 @@
       </p:sp>
       <p:sp>
         <p:nvSpPr>
-          <p:cNvPr id="11" name="Text 9"/>
+          <p:cNvPr id="12" name="Text 10"/>
           <p:cNvSpPr txBox="1"/>
           <p:nvPr/>
         </p:nvSpPr>
@@ -6770,7 +7121,7 @@
       </p:sp>
       <p:sp>
         <p:nvSpPr>
-          <p:cNvPr id="12" name="Shape 10"/>
+          <p:cNvPr id="13" name="Shape 11"/>
           <p:cNvSpPr/>
           <p:nvPr/>
         </p:nvSpPr>
@@ -6795,7 +7146,7 @@
       </p:sp>
       <p:sp>
         <p:nvSpPr>
-          <p:cNvPr id="13" name="Text 11"/>
+          <p:cNvPr id="14" name="Text 12"/>
           <p:cNvSpPr txBox="1"/>
           <p:nvPr/>
         </p:nvSpPr>
@@ -6834,7 +7185,7 @@
       </p:sp>
       <p:sp>
         <p:nvSpPr>
-          <p:cNvPr id="14" name="Text 12"/>
+          <p:cNvPr id="15" name="Text 13"/>
           <p:cNvSpPr txBox="1"/>
           <p:nvPr/>
         </p:nvSpPr>
@@ -6896,7 +7247,7 @@
       </p:sp>
       <p:sp>
         <p:nvSpPr>
-          <p:cNvPr id="15" name="Shape 13"/>
+          <p:cNvPr id="16" name="Shape 14"/>
           <p:cNvSpPr/>
           <p:nvPr/>
         </p:nvSpPr>
@@ -6921,7 +7272,7 @@
       </p:sp>
       <p:sp>
         <p:nvSpPr>
-          <p:cNvPr id="16" name="Text 14"/>
+          <p:cNvPr id="17" name="Text 15"/>
           <p:cNvSpPr txBox="1"/>
           <p:nvPr/>
         </p:nvSpPr>
@@ -6960,7 +7311,7 @@
       </p:sp>
       <p:sp>
         <p:nvSpPr>
-          <p:cNvPr id="17" name="Text 15"/>
+          <p:cNvPr id="18" name="Text 16"/>
           <p:cNvSpPr txBox="1"/>
           <p:nvPr/>
         </p:nvSpPr>
@@ -7054,7 +7405,7 @@
         <p:spPr>
           <a:xfrm>
             <a:off x="640080" y="457200"/>
-            <a:ext cx="10911535" cy="731520"/>
+            <a:ext cx="9144000" cy="731520"/>
           </a:xfrm>
           <a:prstGeom prst="rect">
             <a:avLst/>
@@ -7087,6 +7438,45 @@
       <p:sp>
         <p:nvSpPr>
           <p:cNvPr id="3" name="Text 1"/>
+          <p:cNvSpPr txBox="1"/>
+          <p:nvPr/>
+        </p:nvSpPr>
+        <p:spPr>
+          <a:xfrm>
+            <a:off x="9722815" y="566928"/>
+            <a:ext cx="1828800" cy="274320"/>
+          </a:xfrm>
+          <a:prstGeom prst="rect">
+            <a:avLst/>
+          </a:prstGeom>
+          <a:noFill/>
+          <a:ln/>
+        </p:spPr>
+        <p:txBody>
+          <a:bodyPr wrap="square" lIns="0" tIns="0" rIns="0" bIns="0" rtlCol="0" anchor="ctr"/>
+          <a:lstStyle/>
+          <a:p>
+            <a:pPr algn="r" indent="0" marL="0">
+              <a:buNone/>
+            </a:pPr>
+            <a:r>
+              <a:rPr lang="en-US" sz="1200" dirty="0">
+                <a:solidFill>
+                  <a:srgbClr val="9CA3AF"/>
+                </a:solidFill>
+                <a:latin typeface="Arial" pitchFamily="34" charset="0"/>
+                <a:ea typeface="Arial" pitchFamily="34" charset="-122"/>
+                <a:cs typeface="Arial" pitchFamily="34" charset="-120"/>
+              </a:rPr>
+              <a:t>9 / 11</a:t>
+            </a:r>
+            <a:endParaRPr lang="en-US" sz="1200" dirty="0"/>
+          </a:p>
+        </p:txBody>
+      </p:sp>
+      <p:sp>
+        <p:nvSpPr>
+          <p:cNvPr id="4" name="Text 2"/>
           <p:cNvSpPr txBox="1"/>
           <p:nvPr/>
         </p:nvSpPr>
@@ -7180,7 +7570,7 @@
       </p:sp>
       <p:pic>
         <p:nvPicPr>
-          <p:cNvPr id="4" name="Image 0" descr="/home/user/ges-2/docs/strategy/deck-images/site.jpg">    </p:cNvPr>
+          <p:cNvPr id="5" name="Image 0" descr="/home/user/ges-2/docs/strategy/deck-images/site.jpg">    </p:cNvPr>
           <p:cNvPicPr>
             <a:picLocks noChangeAspect="1"/>
           </p:cNvPicPr>
@@ -7204,7 +7594,7 @@
       </p:pic>
       <p:sp>
         <p:nvSpPr>
-          <p:cNvPr id="5" name="Shape 2"/>
+          <p:cNvPr id="6" name="Shape 3"/>
           <p:cNvSpPr/>
           <p:nvPr/>
         </p:nvSpPr>

</xml_diff>

<commit_message>
Fix document card and photo alignment, add PDF exports
</commit_message>
<xml_diff>
--- a/docs/strategy/ges2-service-cx-proposal.pptx
+++ b/docs/strategy/ges2-service-cx-proposal.pptx
@@ -6318,7 +6318,7 @@
         </p:blipFill>
         <p:spPr>
           <a:xfrm>
-            <a:off x="640080" y="1783080"/>
+            <a:off x="640080" y="2505456"/>
             <a:ext cx="3931920" cy="2621280"/>
           </a:xfrm>
           <a:prstGeom prst="rect">
@@ -6334,7 +6334,7 @@
         </p:nvSpPr>
         <p:spPr>
           <a:xfrm>
-            <a:off x="640080" y="1783080"/>
+            <a:off x="640080" y="2505456"/>
             <a:ext cx="3931920" cy="2621280"/>
           </a:xfrm>
           <a:prstGeom prst="rect">
@@ -6813,7 +6813,7 @@
         </p:nvSpPr>
         <p:spPr>
           <a:xfrm>
-            <a:off x="841248" y="3566160"/>
+            <a:off x="841248" y="2432304"/>
             <a:ext cx="1609344" cy="1097280"/>
           </a:xfrm>
           <a:prstGeom prst="rect">
@@ -6823,7 +6823,7 @@
           <a:ln/>
         </p:spPr>
         <p:txBody>
-          <a:bodyPr wrap="square" lIns="0" tIns="0" rIns="0" bIns="0" rtlCol="0" anchor="b"/>
+          <a:bodyPr wrap="square" lIns="0" tIns="0" rIns="0" bIns="0" rtlCol="0" anchor="t"/>
           <a:lstStyle/>
           <a:p>
             <a:pPr indent="0" marL="0">
@@ -6939,7 +6939,7 @@
         </p:nvSpPr>
         <p:spPr>
           <a:xfrm>
-            <a:off x="3063240" y="3566160"/>
+            <a:off x="3063240" y="2432304"/>
             <a:ext cx="1609344" cy="1097280"/>
           </a:xfrm>
           <a:prstGeom prst="rect">
@@ -6949,7 +6949,7 @@
           <a:ln/>
         </p:spPr>
         <p:txBody>
-          <a:bodyPr wrap="square" lIns="0" tIns="0" rIns="0" bIns="0" rtlCol="0" anchor="b"/>
+          <a:bodyPr wrap="square" lIns="0" tIns="0" rIns="0" bIns="0" rtlCol="0" anchor="t"/>
           <a:lstStyle/>
           <a:p>
             <a:pPr indent="0" marL="0">
@@ -7065,7 +7065,7 @@
         </p:nvSpPr>
         <p:spPr>
           <a:xfrm>
-            <a:off x="5285232" y="3566160"/>
+            <a:off x="5285232" y="2432304"/>
             <a:ext cx="1609344" cy="1097280"/>
           </a:xfrm>
           <a:prstGeom prst="rect">
@@ -7075,7 +7075,7 @@
           <a:ln/>
         </p:spPr>
         <p:txBody>
-          <a:bodyPr wrap="square" lIns="0" tIns="0" rIns="0" bIns="0" rtlCol="0" anchor="b"/>
+          <a:bodyPr wrap="square" lIns="0" tIns="0" rIns="0" bIns="0" rtlCol="0" anchor="t"/>
           <a:lstStyle/>
           <a:p>
             <a:pPr indent="0" marL="0">
@@ -7191,7 +7191,7 @@
         </p:nvSpPr>
         <p:spPr>
           <a:xfrm>
-            <a:off x="7507224" y="3566160"/>
+            <a:off x="7507224" y="2432304"/>
             <a:ext cx="1609344" cy="1097280"/>
           </a:xfrm>
           <a:prstGeom prst="rect">
@@ -7201,7 +7201,7 @@
           <a:ln/>
         </p:spPr>
         <p:txBody>
-          <a:bodyPr wrap="square" lIns="0" tIns="0" rIns="0" bIns="0" rtlCol="0" anchor="b"/>
+          <a:bodyPr wrap="square" lIns="0" tIns="0" rIns="0" bIns="0" rtlCol="0" anchor="t"/>
           <a:lstStyle/>
           <a:p>
             <a:pPr indent="0" marL="0">
@@ -7317,7 +7317,7 @@
         </p:nvSpPr>
         <p:spPr>
           <a:xfrm>
-            <a:off x="9729216" y="3566160"/>
+            <a:off x="9729216" y="2432304"/>
             <a:ext cx="1609344" cy="1097280"/>
           </a:xfrm>
           <a:prstGeom prst="rect">
@@ -7327,7 +7327,7 @@
           <a:ln/>
         </p:spPr>
         <p:txBody>
-          <a:bodyPr wrap="square" lIns="0" tIns="0" rIns="0" bIns="0" rtlCol="0" anchor="b"/>
+          <a:bodyPr wrap="square" lIns="0" tIns="0" rIns="0" bIns="0" rtlCol="0" anchor="t"/>
           <a:lstStyle/>
           <a:p>
             <a:pPr indent="0" marL="0">

</xml_diff>